<commit_message>
did some offline mining (Worked a lot in the background)
</commit_message>
<xml_diff>
--- a/docs/Mizan-Farq-2026.pptx
+++ b/docs/Mizan-Farq-2026.pptx
@@ -451,6 +451,11 @@
             <c:idx val="0"/>
             <c:invertIfNegative val="0"/>
             <c:bubble3D val="0"/>
+            <c:spPr>
+              <a:solidFill>
+                <a:srgbClr val="CFC3B3"/>
+              </a:solidFill>
+            </c:spPr>
             <c:extLst>
               <c:ext xmlns:c16="http://schemas.microsoft.com/office/drawing/2014/chart" uri="{C3380CC4-5D6E-409C-BE32-E72D297353CC}">
                 <c16:uniqueId val="{00000001-1DDF-4958-B726-B6501121E071}"/>
@@ -463,7 +468,7 @@
             <c:bubble3D val="0"/>
             <c:spPr>
               <a:solidFill>
-                <a:srgbClr val="F4A252"/>
+                <a:srgbClr val="E3C9A0"/>
               </a:solidFill>
               <a:effectLst/>
             </c:spPr>
@@ -472,6 +477,14 @@
                 <c16:uniqueId val="{00000003-1DDF-4958-B726-B6501121E071}"/>
               </c:ext>
             </c:extLst>
+          </c:dPt>
+          <c:dPt>
+            <c:idx val="2"/>
+            <c:spPr>
+              <a:solidFill>
+                <a:srgbClr val="F4A252"/>
+              </a:solidFill>
+            </c:spPr>
           </c:dPt>
           <c:dLbls>
             <c:numFmt formatCode="#,##0" sourceLinked="0"/>
@@ -512,13 +525,16 @@
           </c:dLbls>
           <c:cat>
             <c:strRef>
-              <c:f>Sheet1!$A$2:$A$3</c:f>
+              <c:f>Sheet1!$A$2:$A$4</c:f>
               <c:strCache>
-                <c:ptCount val="2"/>
+                <c:ptCount val="3"/>
                 <c:pt idx="0">
-                  <c:v>Base model</c:v>
+                  <c:v>Base, old prompt</c:v>
                 </c:pt>
                 <c:pt idx="1">
+                  <c:v>Base, new prompt</c:v>
+                </c:pt>
+                <c:pt idx="2">
                   <c:v>Fine-tuned</c:v>
                 </c:pt>
               </c:strCache>
@@ -526,15 +542,18 @@
           </c:cat>
           <c:val>
             <c:numRef>
-              <c:f>Sheet1!$B$2:$B$3</c:f>
+              <c:f>Sheet1!$B$2:$B$4</c:f>
               <c:numCache>
                 <c:formatCode>General</c:formatCode>
-                <c:ptCount val="2"/>
+                <c:ptCount val="3"/>
                 <c:pt idx="0">
                   <c:v>75</c:v>
                 </c:pt>
                 <c:pt idx="1">
-                  <c:v>111</c:v>
+                  <c:v>96</c:v>
+                </c:pt>
+                <c:pt idx="2">
+                  <c:v>106</c:v>
                 </c:pt>
               </c:numCache>
             </c:numRef>
@@ -1171,12 +1190,27 @@
           <a:lstStyle/>
           <a:p>
             <a:r>
-              <a:rPr lang="en-US" dirty="0"/>
-              <a:t>[Speaker 2 · 2:15–3:15 · LIVE DEMO — switch to the app]
-1. Overview: "This is a demo semester: 1,500 synthetic students, deliberately badly scheduled, 10 hours of gaps each per week." (Say clearly it is synthetic.)
-2. Click Optimize semester → Run (15 s). "The solver searches valid timetables; every result is re-checked by a separate validator."
-3. Evidence: about 1,800 student-hours a week recovered, about 225 students better off, 0 worse off, 0 conflicts. Point at the four steps: Preview, Propose, Approve, Publish. "Nothing changes until a person approves and publishes."
-Fallback if the laptop fails: play the recorded demo video, or stay on this slide.</a:t>
+              <a:t>[Speaker 2 · 2:15–3:15 · LIVE DEMO — switch to the app]</a:t>
+            </a:r>
+          </a:p>
+          <a:p>
+            <a:r>
+              <a:t>1. Overview: "This is a demo semester: 1,500 synthetic students, deliberately badly scheduled, 10 hours of gaps each per week." (Say clearly it is synthetic, and why: "the starting timetable is deliberately poor — identical cohorts with built-in gaps — so the first improvements are obvious. The point is that every change is checked by an independent validator and approved by a person.")</a:t>
+            </a:r>
+          </a:p>
+          <a:p>
+            <a:r>
+              <a:t>2. Click Optimize semester → Run (15 s). "The solver searches valid timetables; every result is re-checked by a separate validator."</a:t>
+            </a:r>
+          </a:p>
+          <a:p>
+            <a:r>
+              <a:t>3. Evidence: about 1,800 student-hours a week recovered, about 225 students better off, 0 worse off, 0 conflicts. Point at the four steps: Preview, Propose, Approve, Publish. "Nothing changes until a person approves and publishes."</a:t>
+            </a:r>
+          </a:p>
+          <a:p>
+            <a:r>
+              <a:t>Fallback if the laptop fails: play the recorded demo video, or stay on this slide.</a:t>
             </a:r>
           </a:p>
         </p:txBody>
@@ -1352,12 +1386,27 @@
           <a:lstStyle/>
           <a:p>
             <a:r>
-              <a:rPr lang="en-US" dirty="0"/>
-              <a:t>[Speaker 3 · 3:45–4:20]
-"Three reasons to trust it. One: the AI runs on this laptop. No cloud, no student data leaves the university. We fine-tuned the coordinator agent: on 120 test decisions it went from 75 correct to 111.
-Two: the AI never decides a hard rule. An OR-Tools solver finds valid timetables, and a separate validator re-checks every result. If it cannot prove a result is optimal, it says so.
-Three: 86 automated tests, three browser suites, every acceptance criterion mapped to a passing test, and Arabic and English always show the same numbers."
-Q&amp;A detail: 73→116 on the frozen NF4 test; 75→111 on the live model (p≈1e-7). The test cases come from the same generator as the training data.</a:t>
+              <a:t>[Speaker 3 · 3:45–4:20]</a:t>
+            </a:r>
+          </a:p>
+          <a:p>
+            <a:r>
+              <a:t>"Three reasons to trust it. One: the AI runs on this laptop. No cloud, no student data leaves the university. We tested the coordinator agent on 120 synthetic decisions: a better prompt took the base model from 75 to 96 correct, and fine-tuning added about 10 more, to 106 — mostly finishing changed timetables and ignoring injected instructions.</a:t>
+            </a:r>
+          </a:p>
+          <a:p>
+            <a:r>
+              <a:t>Two: the AI never decides a hard rule or the final outcome. An OR-Tools solver finds valid timetables, and a separate validator re-checks every result. If it cannot prove a result is optimal, it says so.</a:t>
+            </a:r>
+          </a:p>
+          <a:p>
+            <a:r>
+              <a:t>Three: 99 automated tests, three browser suites, every acceptance criterion mapped to a passing test, and Arabic and English always show the same numbers."</a:t>
+            </a:r>
+          </a:p>
+          <a:p>
+            <a:r>
+              <a:t>Q&amp;A detail: fine-tuning alone (same prompt): 14 decisions fixed, 4 broken, p ≈ 0.03. The cases come from the same generator as the training data, so this measures the workflow, not real-world ability. Do not quote the older "111 vs 75" — it changed the prompt and the adapter together. Source: training/coordinator/deployed_ablation.md.</a:t>
             </a:r>
           </a:p>
         </p:txBody>
@@ -6576,7 +6625,7 @@
                 <a:ea typeface="Arial" pitchFamily="34" charset="-122"/>
                 <a:cs typeface="Arial" pitchFamily="34" charset="-120"/>
               </a:rPr>
-              <a:t>Demo semester: 1,500 synthetic students with a deliberately poor start (10 h of gaps each per week).</a:t>
+              <a:t>Demo semester: 1,500 synthetic students. The start is deliberately poor (identical cohorts, 10 h of gaps each), so the first moves are obvious; the point is that every change is checked and approved.</a:t>
             </a:r>
             <a:endParaRPr lang="en-US" sz="2420" dirty="0"/>
           </a:p>
@@ -7587,7 +7636,7 @@
                 <a:ea typeface="Arial" pitchFamily="34" charset="-122"/>
                 <a:cs typeface="Arial" pitchFamily="34" charset="-120"/>
               </a:rPr>
-              <a:t>We fine-tuned the coordinator agent. Correct decisions out of 120 test cases:</a:t>
+              <a:t>We fine-tuned the coordinator agent. Correct decisions out of 120 synthetic test cases:</a:t>
             </a:r>
             <a:endParaRPr lang="en-US" sz="3140" dirty="0"/>
           </a:p>
@@ -7752,7 +7801,7 @@
                 <a:ea typeface="Arial" pitchFamily="34" charset="-122"/>
                 <a:cs typeface="Arial" pitchFamily="34" charset="-120"/>
               </a:rPr>
-              <a:t>86 automated tests and 3 browser test suites pass.</a:t>
+              <a:t>99 automated tests and 3 browser test suites pass.</a:t>
             </a:r>
             <a:endParaRPr lang="en-US" sz="3140" dirty="0"/>
           </a:p>

</xml_diff>

<commit_message>
Changed the breifing, and made a pptx
</commit_message>
<xml_diff>
--- a/docs/Mizan-Farq-2026.pptx
+++ b/docs/Mizan-Farq-2026.pptx
@@ -12,8 +12,6 @@
     <p:sldId id="257" r:id="rId3"/>
     <p:sldId id="258" r:id="rId4"/>
     <p:sldId id="259" r:id="rId5"/>
-    <p:sldId id="260" r:id="rId6"/>
-    <p:sldId id="261" r:id="rId7"/>
     <p:sldId id="262" r:id="rId8"/>
     <p:sldId id="263" r:id="rId9"/>
   </p:sldIdLst>
@@ -155,263 +153,6 @@
 </p:presentation>
 </file>
 
-<file path=ppt/charts/chart1.xml><?xml version="1.0" encoding="utf-8"?>
-<c:chartSpace xmlns:c="http://schemas.openxmlformats.org/drawingml/2006/chart" xmlns:a="http://schemas.openxmlformats.org/drawingml/2006/main" xmlns:r="http://schemas.openxmlformats.org/officeDocument/2006/relationships" xmlns:c16r2="http://schemas.microsoft.com/office/drawing/2015/06/chart">
-  <c:date1904 val="0"/>
-  <c:lang val="en-US"/>
-  <c:roundedCorners val="1"/>
-  <c:style val="2"/>
-  <c:chart>
-    <c:title>
-      <c:tx>
-        <c:rich>
-          <a:bodyPr/>
-          <a:lstStyle/>
-          <a:p>
-            <a:pPr>
-              <a:defRPr sz="2900" b="0" i="0" u="none" strike="noStrike">
-                <a:solidFill>
-                  <a:srgbClr val="172126"/>
-                </a:solidFill>
-                <a:latin typeface="+mn-lt"/>
-              </a:defRPr>
-            </a:pPr>
-            <a:r>
-              <a:rPr lang="en-US" sz="2900" b="0" i="0" u="none" strike="noStrike">
-                <a:solidFill>
-                  <a:srgbClr val="172126"/>
-                </a:solidFill>
-                <a:latin typeface="+mn-lt"/>
-              </a:rPr>
-              <a:t>Student gap hours per week</a:t>
-            </a:r>
-          </a:p>
-        </c:rich>
-      </c:tx>
-      <c:overlay val="0"/>
-    </c:title>
-    <c:autoTitleDeleted val="0"/>
-    <c:plotArea>
-      <c:layout/>
-      <c:barChart>
-        <c:barDir val="col"/>
-        <c:grouping val="clustered"/>
-        <c:varyColors val="0"/>
-        <c:ser>
-          <c:idx val="0"/>
-          <c:order val="0"/>
-          <c:tx>
-            <c:strRef>
-              <c:f>Sheet1!$B$1</c:f>
-              <c:strCache>
-                <c:ptCount val="1"/>
-                <c:pt idx="0">
-                  <c:v>Student gap hours per week</c:v>
-                </c:pt>
-              </c:strCache>
-            </c:strRef>
-          </c:tx>
-          <c:spPr>
-            <a:solidFill>
-              <a:srgbClr val="B95042"/>
-            </a:solidFill>
-            <a:effectLst/>
-          </c:spPr>
-          <c:invertIfNegative val="0"/>
-          <c:dPt>
-            <c:idx val="0"/>
-            <c:invertIfNegative val="0"/>
-            <c:bubble3D val="0"/>
-            <c:extLst>
-              <c:ext xmlns:c16="http://schemas.microsoft.com/office/drawing/2014/chart" uri="{C3380CC4-5D6E-409C-BE32-E72D297353CC}">
-                <c16:uniqueId val="{00000001-826A-4A9C-8D81-FF3384971CCA}"/>
-              </c:ext>
-            </c:extLst>
-          </c:dPt>
-          <c:dPt>
-            <c:idx val="1"/>
-            <c:invertIfNegative val="0"/>
-            <c:bubble3D val="0"/>
-            <c:spPr>
-              <a:solidFill>
-                <a:srgbClr val="529573"/>
-              </a:solidFill>
-              <a:effectLst/>
-            </c:spPr>
-            <c:extLst>
-              <c:ext xmlns:c16="http://schemas.microsoft.com/office/drawing/2014/chart" uri="{C3380CC4-5D6E-409C-BE32-E72D297353CC}">
-                <c16:uniqueId val="{00000003-826A-4A9C-8D81-FF3384971CCA}"/>
-              </c:ext>
-            </c:extLst>
-          </c:dPt>
-          <c:dLbls>
-            <c:numFmt formatCode="#,##0" sourceLinked="0"/>
-            <c:spPr>
-              <a:noFill/>
-              <a:ln>
-                <a:noFill/>
-              </a:ln>
-              <a:effectLst/>
-            </c:spPr>
-            <c:txPr>
-              <a:bodyPr/>
-              <a:lstStyle/>
-              <a:p>
-                <a:pPr>
-                  <a:defRPr sz="2900" b="0" i="0" u="none" strike="noStrike">
-                    <a:solidFill>
-                      <a:srgbClr val="172126"/>
-                    </a:solidFill>
-                    <a:latin typeface="+mn-lt"/>
-                  </a:defRPr>
-                </a:pPr>
-                <a:endParaRPr lang="en-US"/>
-              </a:p>
-            </c:txPr>
-            <c:showLegendKey val="0"/>
-            <c:showVal val="1"/>
-            <c:showCatName val="0"/>
-            <c:showSerName val="0"/>
-            <c:showPercent val="0"/>
-            <c:showBubbleSize val="0"/>
-            <c:showLeaderLines val="0"/>
-            <c:extLst>
-              <c:ext xmlns:c15="http://schemas.microsoft.com/office/drawing/2012/chart" uri="{CE6537A1-D6FC-4f65-9D91-7224C49458BB}">
-                <c15:showLeaderLines val="0"/>
-              </c:ext>
-            </c:extLst>
-          </c:dLbls>
-          <c:cat>
-            <c:strRef>
-              <c:f>Sheet1!$A$2:$A$3</c:f>
-              <c:strCache>
-                <c:ptCount val="2"/>
-                <c:pt idx="0">
-                  <c:v>Before</c:v>
-                </c:pt>
-                <c:pt idx="1">
-                  <c:v>After 15 s</c:v>
-                </c:pt>
-              </c:strCache>
-            </c:strRef>
-          </c:cat>
-          <c:val>
-            <c:numRef>
-              <c:f>Sheet1!$B$2:$B$3</c:f>
-              <c:numCache>
-                <c:formatCode>General</c:formatCode>
-                <c:ptCount val="2"/>
-                <c:pt idx="0">
-                  <c:v>15000</c:v>
-                </c:pt>
-                <c:pt idx="1">
-                  <c:v>13200</c:v>
-                </c:pt>
-              </c:numCache>
-            </c:numRef>
-          </c:val>
-          <c:extLst>
-            <c:ext xmlns:c16="http://schemas.microsoft.com/office/drawing/2014/chart" uri="{C3380CC4-5D6E-409C-BE32-E72D297353CC}">
-              <c16:uniqueId val="{00000004-826A-4A9C-8D81-FF3384971CCA}"/>
-            </c:ext>
-          </c:extLst>
-        </c:ser>
-        <c:dLbls>
-          <c:showLegendKey val="0"/>
-          <c:showVal val="1"/>
-          <c:showCatName val="0"/>
-          <c:showSerName val="0"/>
-          <c:showPercent val="0"/>
-          <c:showBubbleSize val="0"/>
-        </c:dLbls>
-        <c:gapWidth val="60"/>
-        <c:axId val="2094734554"/>
-        <c:axId val="2094734552"/>
-      </c:barChart>
-      <c:catAx>
-        <c:axId val="2094734554"/>
-        <c:scaling>
-          <c:orientation val="minMax"/>
-        </c:scaling>
-        <c:delete val="0"/>
-        <c:axPos val="b"/>
-        <c:numFmt formatCode="General" sourceLinked="1"/>
-        <c:majorTickMark val="out"/>
-        <c:minorTickMark val="none"/>
-        <c:tickLblPos val="low"/>
-        <c:spPr>
-          <a:ln w="12700" cap="flat">
-            <a:solidFill>
-              <a:srgbClr val="888888"/>
-            </a:solidFill>
-            <a:prstDash val="solid"/>
-            <a:round/>
-          </a:ln>
-        </c:spPr>
-        <c:txPr>
-          <a:bodyPr/>
-          <a:lstStyle/>
-          <a:p>
-            <a:pPr>
-              <a:defRPr sz="2660" b="0" i="0" u="none" strike="noStrike">
-                <a:solidFill>
-                  <a:srgbClr val="68645B"/>
-                </a:solidFill>
-                <a:latin typeface="+mn-lt"/>
-              </a:defRPr>
-            </a:pPr>
-            <a:endParaRPr lang="en-US"/>
-          </a:p>
-        </c:txPr>
-        <c:crossAx val="2094734552"/>
-        <c:crosses val="autoZero"/>
-        <c:auto val="1"/>
-        <c:lblAlgn val="ctr"/>
-        <c:lblOffset val="100"/>
-        <c:noMultiLvlLbl val="1"/>
-      </c:catAx>
-      <c:valAx>
-        <c:axId val="2094734552"/>
-        <c:scaling>
-          <c:orientation val="minMax"/>
-          <c:max val="17000"/>
-          <c:min val="0"/>
-        </c:scaling>
-        <c:delete val="1"/>
-        <c:axPos val="l"/>
-        <c:numFmt formatCode="General" sourceLinked="0"/>
-        <c:majorTickMark val="out"/>
-        <c:minorTickMark val="none"/>
-        <c:tickLblPos val="nextTo"/>
-        <c:crossAx val="2094734554"/>
-        <c:crosses val="autoZero"/>
-        <c:crossBetween val="between"/>
-      </c:valAx>
-      <c:spPr>
-        <a:noFill/>
-        <a:ln>
-          <a:noFill/>
-        </a:ln>
-        <a:effectLst/>
-      </c:spPr>
-    </c:plotArea>
-    <c:plotVisOnly val="1"/>
-    <c:dispBlanksAs val="span"/>
-    <c:showDLblsOverMax val="1"/>
-  </c:chart>
-  <c:spPr>
-    <a:noFill/>
-    <a:ln>
-      <a:noFill/>
-    </a:ln>
-    <a:effectLst/>
-  </c:spPr>
-  <c:externalData r:id="rId1">
-    <c:autoUpdate val="0"/>
-  </c:externalData>
-</c:chartSpace>
-</file>
-
 <file path=ppt/charts/chart2.xml><?xml version="1.0" encoding="utf-8"?>
 <c:chartSpace xmlns:c="http://schemas.openxmlformats.org/drawingml/2006/chart" xmlns:a="http://schemas.openxmlformats.org/drawingml/2006/main" xmlns:r="http://schemas.openxmlformats.org/officeDocument/2006/relationships" xmlns:c16r2="http://schemas.microsoft.com/office/drawing/2015/06/chart">
   <c:date1904 val="0"/>
@@ -480,11 +221,18 @@
           </c:dPt>
           <c:dPt>
             <c:idx val="2"/>
+            <c:invertIfNegative val="1"/>
+            <c:bubble3D val="0"/>
             <c:spPr>
               <a:solidFill>
                 <a:srgbClr val="F4A252"/>
               </a:solidFill>
             </c:spPr>
+            <c:extLst>
+              <c:ext xmlns:c16="http://schemas.microsoft.com/office/drawing/2014/chart" uri="{C3380CC4-5D6E-409C-BE32-E72D297353CC}">
+                <c16:uniqueId val="{00000005-1647-4C4E-9E11-F0282D80C612}"/>
+              </c:ext>
+            </c:extLst>
           </c:dPt>
           <c:dLbls>
             <c:numFmt formatCode="#,##0" sourceLinked="0"/>
@@ -830,10 +578,17 @@
           <a:lstStyle/>
           <a:p>
             <a:r>
-              <a:rPr lang="en-US" dirty="0"/>
-              <a:t>[Whole team on stage · 0:00–0:30]
-Speaker 1: "We are team Mizan." Each member says their name and role in one line (edit the four cards on this slide).
-Speaker 1: "Mizan is a local AI assistant that turns a valid university timetable into a better one for students, and every change still goes through people."</a:t>
+              <a:t>[0:00–0:20 · Whole team · 20 s]</a:t>
+            </a:r>
+          </a:p>
+          <a:p>
+            <a:r>
+              <a:t>SULTAN: "Good morning. We are team Mizan." (Sultan, Ali and Mishary each say their name and role in one line, as on the cards.)</a:t>
+            </a:r>
+          </a:p>
+          <a:p>
+            <a:r>
+              <a:t>SULTAN: "Mizan is a local AI assistant that makes a university timetable better for students — and every change still goes through a person." </a:t>
             </a:r>
           </a:p>
         </p:txBody>
@@ -919,13 +674,37 @@
           <a:lstStyle/>
           <a:p>
             <a:r>
-              <a:rPr lang="en-US" dirty="0"/>
-              <a:t>[Speaker 1 · 0:30–1:15]
-"Research links timetables to attendance. At Prince Sultan University in Riyadh, three timetable factors predicted student absences with 87% accuracy, and one of them is the free time between classes. In the same study, absences track GPA closely, a correlation of −0.71.
-A UK study with randomly assigned timetables found the same direction: back-to-back classes raise attendance, single-class days lower it.
-And rooms: across 30+ UK universities, teaching rooms are used about 20% of the time.
-So the timetable is a lever universities already control, but it is built to be valid, not to be good for students."
-Note for Q&amp;A: we do NOT claim Mizan raises grades; the grade link is correlational. We claim student time and attendance.</a:t>
+              <a:t>[0:20–1:00 · Sultan · 40 s]</a:t>
+            </a:r>
+          </a:p>
+          <a:p>
+            <a:r>
+              <a:t>"A timetable decides when students come, wait and leave. Research shows it matters.</a:t>
+            </a:r>
+          </a:p>
+          <a:p>
+            <a:r>
+              <a:t>At Prince Sultan University in Riyadh, three timetable factors predicted absences with 87% accuracy — one is free time between classes. In the same study, more absences meant lower GPA: a correlation of −0.71.</a:t>
+            </a:r>
+          </a:p>
+          <a:p>
+            <a:r>
+              <a:t>A UK study with randomly assigned timetables found the same: back-to-back classes raise attendance; single-class days lower it.</a:t>
+            </a:r>
+          </a:p>
+          <a:p>
+            <a:r>
+              <a:t>And rooms sit empty: about 20% use across 30 UK universities.</a:t>
+            </a:r>
+          </a:p>
+          <a:p>
+            <a:r>
+              <a:t>The timetable is a lever every university controls — but today it is built to be valid, not good for students."</a:t>
+            </a:r>
+          </a:p>
+          <a:p>
+            <a:r>
+              <a:t>Q&amp;A note: we do NOT claim higher grades; the grade link is a correlation. We claim attendance and student time.</a:t>
             </a:r>
           </a:p>
         </p:txBody>
@@ -1011,11 +790,22 @@
           <a:lstStyle/>
           <a:p>
             <a:r>
-              <a:rPr lang="en-US" dirty="0"/>
-              <a:t>[Speaker 1 · 1:15–1:45]
-"Why don't universities just improve their timetables? Because every change ripples. Move one class and you must re-check the room, the professor, and every student enrolled, plus every other section they take.
-We collected 30 real requests from professors: move my class, find a time for a quiz, merge two sections. Each one is a small optimization problem.
-In our demo semester, moving a single section to Sunday at 10 creates 77 student clashes. Doing this by hand doesn't scale."</a:t>
+              <a:t>[1:00–1:25 · Sultan · 25 s]</a:t>
+            </a:r>
+          </a:p>
+          <a:p>
+            <a:r>
+              <a:t>"Why not just improve it? Because every change ripples: move one class and you re-check the room, the professor, every enrolled student and their other classes.</a:t>
+            </a:r>
+          </a:p>
+          <a:p>
+            <a:r>
+              <a:t>We collected 30 real requests from professors — move a class, find a quiz time, merge two sections.</a:t>
+            </a:r>
+          </a:p>
+          <a:p>
+            <a:r>
+              <a:t>In our demo, one move to Sunday 10:00 creates 77 conflicts. By hand, this doesn't scale." </a:t>
             </a:r>
           </a:p>
         </p:txBody>
@@ -1101,10 +891,92 @@
           <a:lstStyle/>
           <a:p>
             <a:r>
-              <a:rPr lang="en-US" dirty="0"/>
-              <a:t>[Speaker 2 · 1:45–2:15]
-"Mizan works in five steps. Import: a whole semester, or a single student's Edugate PDF or app screenshot. Measure: gap hours, campus days, room use. Improve: an optimization solver searches thousands of valid timetables, and six AI agents explain the trade-offs. Approve: the committee sees the evidence; nothing is published without a person. Export: back to the Edugate layout.
-It serves the committee, chairs, professors (who can ask in Arabic or English), students, and hiring managers when a shortage is proven."</a:t>
+              <a:t>[1:25–1:50 · Mishary · 25 s]</a:t>
+            </a:r>
+          </a:p>
+          <a:p>
+            <a:r>
+              <a:t>"Mizan works in five steps. Import a whole semester — or a single student's Edugate PDF or app screenshot. Measure gaps, campus days and room use. Improve with a solver that only proposes valid timetables. Approve: the committee sees benefit and harm side by side. Export back to the Edugate layout.</a:t>
+            </a:r>
+          </a:p>
+          <a:p>
+            <a:r>
+              <a:t>It serves the committee, chairs, professors, students and hiring managers. Ali will show you." </a:t>
+            </a:r>
+          </a:p>
+          <a:p>
+            <a:r>
+              <a:t/>
+            </a:r>
+          </a:p>
+          <a:p>
+            <a:r>
+              <a:t/>
+            </a:r>
+          </a:p>
+          <a:p>
+            <a:r>
+              <a:t>→ SWITCH TO THE BROWSER (Ali). Back to the deck afterwards, on the Trust slide.</a:t>
+            </a:r>
+          </a:p>
+          <a:p>
+            <a:r>
+              <a:t/>
+            </a:r>
+          </a:p>
+          <a:p>
+            <a:r>
+              <a:t>[1:50–3:00 · Ali · LIVE DEMO · 70 s] (laptop; no AI needed for this part)</a:t>
+            </a:r>
+          </a:p>
+          <a:p>
+            <a:r>
+              <a:t>1. Overview: "This demo semester has 1,500 synthetic students. Its start is deliberately poor: 10 hours of gaps each per week. The point is the method."</a:t>
+            </a:r>
+          </a:p>
+          <a:p>
+            <a:r>
+              <a:t>2. Optimize semester → Run (15 s). While it runs: "The solver searches valid timetables, and a separate validator re-checks every result."</a:t>
+            </a:r>
+          </a:p>
+          <a:p>
+            <a:r>
+              <a:t>3. Evidence: "About 1,800 student-hours a week given back, 225 students better off, zero worse off, zero conflicts — benefit and harm shown separately."</a:t>
+            </a:r>
+          </a:p>
+          <a:p>
+            <a:r>
+              <a:t>4. Approve → the dialog stays open → Publish: "Nothing changes until a person approves and publishes."</a:t>
+            </a:r>
+          </a:p>
+          <a:p>
+            <a:r>
+              <a:t>If anything fails: play the backup demo video on the desktop.</a:t>
+            </a:r>
+          </a:p>
+          <a:p>
+            <a:r>
+              <a:t/>
+            </a:r>
+          </a:p>
+          <a:p>
+            <a:r>
+              <a:t>[3:00–3:30 · Ali · LIVE · 30 s]</a:t>
+            </a:r>
+          </a:p>
+          <a:p>
+            <a:r>
+              <a:t>"It also speaks Al Yamamah's own format." Semester lab → Edugate import: upload the app screenshot (reads in about a second, on this laptop; the file isn't stored). "Anything unsure is highlighted for you to check."</a:t>
+            </a:r>
+          </a:p>
+          <a:p>
+            <a:r>
+              <a:t>Then download the prepared PDF: "The result comes back in the Edugate layout, changed rows shaded. Instructors and room sizes aren't on a student schedule, so Mizan marks them as assumed and won't publish until they're verified."</a:t>
+            </a:r>
+          </a:p>
+          <a:p>
+            <a:r>
+              <a:t>Before the pitch: import your schedule and optimize it once, so the export is ready.</a:t>
             </a:r>
           </a:p>
         </p:txBody>
@@ -1127,202 +999,6 @@
             <a:fld id="{F7021451-1387-4CA6-816F-3879F97B5CBC}" type="slidenum">
               <a:rPr lang="en-US"/>
               <a:t>4</a:t>
-            </a:fld>
-            <a:endParaRPr lang="en-US"/>
-          </a:p>
-        </p:txBody>
-      </p:sp>
-    </p:spTree>
-    <p:extLst>
-      <p:ext uri="{BB962C8B-B14F-4D97-AF65-F5344CB8AC3E}">
-        <p14:creationId xmlns:p14="http://schemas.microsoft.com/office/powerpoint/2010/main" val="1024086991"/>
-      </p:ext>
-    </p:extLst>
-  </p:cSld>
-  <p:clrMapOvr>
-    <a:masterClrMapping/>
-  </p:clrMapOvr>
-</p:notes>
-</file>
-
-<file path=ppt/notesSlides/notesSlide5.xml><?xml version="1.0" encoding="utf-8"?>
-<p:notes xmlns:a="http://schemas.openxmlformats.org/drawingml/2006/main" xmlns:r="http://schemas.openxmlformats.org/officeDocument/2006/relationships" xmlns:p="http://schemas.openxmlformats.org/presentationml/2006/main">
-  <p:cSld>
-    <p:spTree>
-      <p:nvGrpSpPr>
-        <p:cNvPr id="1" name=""/>
-        <p:cNvGrpSpPr/>
-        <p:nvPr/>
-      </p:nvGrpSpPr>
-      <p:grpSpPr>
-        <a:xfrm>
-          <a:off x="0" y="0"/>
-          <a:ext cx="0" cy="0"/>
-          <a:chOff x="0" y="0"/>
-          <a:chExt cx="0" cy="0"/>
-        </a:xfrm>
-      </p:grpSpPr>
-      <p:sp>
-        <p:nvSpPr>
-          <p:cNvPr id="2" name="Slide Image Placeholder 1"/>
-          <p:cNvSpPr>
-            <a:spLocks noGrp="1" noRot="1" noChangeAspect="1"/>
-          </p:cNvSpPr>
-          <p:nvPr>
-            <p:ph type="sldImg"/>
-          </p:nvPr>
-        </p:nvSpPr>
-        <p:spPr/>
-      </p:sp>
-      <p:sp>
-        <p:nvSpPr>
-          <p:cNvPr id="3" name="Notes Placeholder 2"/>
-          <p:cNvSpPr>
-            <a:spLocks noGrp="1"/>
-          </p:cNvSpPr>
-          <p:nvPr>
-            <p:ph type="body" idx="1"/>
-          </p:nvPr>
-        </p:nvSpPr>
-        <p:spPr/>
-        <p:txBody>
-          <a:bodyPr/>
-          <a:lstStyle/>
-          <a:p>
-            <a:r>
-              <a:t>[Speaker 2 · 2:15–3:15 · LIVE DEMO — switch to the app]</a:t>
-            </a:r>
-          </a:p>
-          <a:p>
-            <a:r>
-              <a:t>1. Overview: "This is a demo semester: 1,500 synthetic students, deliberately badly scheduled, 10 hours of gaps each per week." (Say clearly it is synthetic, and why: "the starting timetable is deliberately poor — identical cohorts with built-in gaps — so the first improvements are obvious. The point is that every change is checked by an independent validator and approved by a person.")</a:t>
-            </a:r>
-          </a:p>
-          <a:p>
-            <a:r>
-              <a:t>2. Click Optimize semester → Run (15 s). "The solver searches valid timetables; every result is re-checked by a separate validator."</a:t>
-            </a:r>
-          </a:p>
-          <a:p>
-            <a:r>
-              <a:t>3. Evidence: about 1,800 student-hours a week recovered, about 225 students better off, 0 worse off, 0 conflicts. Point at the four steps: Preview, Propose, Approve, Publish. "Nothing changes until a person approves and publishes."</a:t>
-            </a:r>
-          </a:p>
-          <a:p>
-            <a:r>
-              <a:t>Fallback if the laptop fails: play the recorded demo video, or stay on this slide.</a:t>
-            </a:r>
-          </a:p>
-        </p:txBody>
-      </p:sp>
-      <p:sp>
-        <p:nvSpPr>
-          <p:cNvPr id="4" name="Slide Number Placeholder 3"/>
-          <p:cNvSpPr>
-            <a:spLocks noGrp="1"/>
-          </p:cNvSpPr>
-          <p:nvPr>
-            <p:ph type="sldNum" sz="quarter" idx="10"/>
-          </p:nvPr>
-        </p:nvSpPr>
-        <p:spPr/>
-        <p:txBody>
-          <a:bodyPr/>
-          <a:lstStyle/>
-          <a:p>
-            <a:fld id="{F7021451-1387-4CA6-816F-3879F97B5CBC}" type="slidenum">
-              <a:rPr lang="en-US"/>
-              <a:t>5</a:t>
-            </a:fld>
-            <a:endParaRPr lang="en-US"/>
-          </a:p>
-        </p:txBody>
-      </p:sp>
-    </p:spTree>
-    <p:extLst>
-      <p:ext uri="{BB962C8B-B14F-4D97-AF65-F5344CB8AC3E}">
-        <p14:creationId xmlns:p14="http://schemas.microsoft.com/office/powerpoint/2010/main" val="1024086991"/>
-      </p:ext>
-    </p:extLst>
-  </p:cSld>
-  <p:clrMapOvr>
-    <a:masterClrMapping/>
-  </p:clrMapOvr>
-</p:notes>
-</file>
-
-<file path=ppt/notesSlides/notesSlide6.xml><?xml version="1.0" encoding="utf-8"?>
-<p:notes xmlns:a="http://schemas.openxmlformats.org/drawingml/2006/main" xmlns:r="http://schemas.openxmlformats.org/officeDocument/2006/relationships" xmlns:p="http://schemas.openxmlformats.org/presentationml/2006/main">
-  <p:cSld>
-    <p:spTree>
-      <p:nvGrpSpPr>
-        <p:cNvPr id="1" name=""/>
-        <p:cNvGrpSpPr/>
-        <p:nvPr/>
-      </p:nvGrpSpPr>
-      <p:grpSpPr>
-        <a:xfrm>
-          <a:off x="0" y="0"/>
-          <a:ext cx="0" cy="0"/>
-          <a:chOff x="0" y="0"/>
-          <a:chExt cx="0" cy="0"/>
-        </a:xfrm>
-      </p:grpSpPr>
-      <p:sp>
-        <p:nvSpPr>
-          <p:cNvPr id="2" name="Slide Image Placeholder 1"/>
-          <p:cNvSpPr>
-            <a:spLocks noGrp="1" noRot="1" noChangeAspect="1"/>
-          </p:cNvSpPr>
-          <p:nvPr>
-            <p:ph type="sldImg"/>
-          </p:nvPr>
-        </p:nvSpPr>
-        <p:spPr/>
-      </p:sp>
-      <p:sp>
-        <p:nvSpPr>
-          <p:cNvPr id="3" name="Notes Placeholder 2"/>
-          <p:cNvSpPr>
-            <a:spLocks noGrp="1"/>
-          </p:cNvSpPr>
-          <p:nvPr>
-            <p:ph type="body" idx="1"/>
-          </p:nvPr>
-        </p:nvSpPr>
-        <p:spPr/>
-        <p:txBody>
-          <a:bodyPr/>
-          <a:lstStyle/>
-          <a:p>
-            <a:r>
-              <a:rPr lang="en-US" dirty="0"/>
-              <a:t>[Speaker 2 · 3:15–3:45 · LIVE: Semester lab → Edugate schedules]
-"Mizan also speaks Al Yamamah's own format. We upload a real Edugate schedule PDF, or a screenshot from the app. Mizan reads it on this laptop, Arabic and English, and the file is never stored. Anything it is unsure of is highlighted: here the end time was cut off in the screenshot, so we type it in.
-Add to Mizan → optimize → and download the result in the same Edugate layout, with the changed rows shaded."
-Q&amp;A: instructors and room sizes are not on a student schedule, so Mizan uses placeholders, and says so on screen.</a:t>
-            </a:r>
-          </a:p>
-        </p:txBody>
-      </p:sp>
-      <p:sp>
-        <p:nvSpPr>
-          <p:cNvPr id="4" name="Slide Number Placeholder 3"/>
-          <p:cNvSpPr>
-            <a:spLocks noGrp="1"/>
-          </p:cNvSpPr>
-          <p:nvPr>
-            <p:ph type="sldNum" sz="quarter" idx="10"/>
-          </p:nvPr>
-        </p:nvSpPr>
-        <p:spPr/>
-        <p:txBody>
-          <a:bodyPr/>
-          <a:lstStyle/>
-          <a:p>
-            <a:fld id="{F7021451-1387-4CA6-816F-3879F97B5CBC}" type="slidenum">
-              <a:rPr lang="en-US"/>
-              <a:t>6</a:t>
             </a:fld>
             <a:endParaRPr lang="en-US"/>
           </a:p>
@@ -1386,27 +1062,27 @@
           <a:lstStyle/>
           <a:p>
             <a:r>
-              <a:t>[Speaker 3 · 3:45–4:20]</a:t>
-            </a:r>
-          </a:p>
-          <a:p>
-            <a:r>
-              <a:t>"Three reasons to trust it. One: the AI runs on this laptop. No cloud, no student data leaves the university. We tested the coordinator agent on 120 synthetic decisions: a better prompt took the base model from 75 to 96 correct, and fine-tuning added about 10 more, to 106 — mostly finishing changed timetables and ignoring injected instructions.</a:t>
-            </a:r>
-          </a:p>
-          <a:p>
-            <a:r>
-              <a:t>Two: the AI never decides a hard rule or the final outcome. An OR-Tools solver finds valid timetables, and a separate validator re-checks every result. If it cannot prove a result is optimal, it says so.</a:t>
-            </a:r>
-          </a:p>
-          <a:p>
-            <a:r>
-              <a:t>Three: 99 automated tests, three browser suites, every acceptance criterion mapped to a passing test, and Arabic and English always show the same numbers."</a:t>
-            </a:r>
-          </a:p>
-          <a:p>
-            <a:r>
-              <a:t>Q&amp;A detail: fine-tuning alone (same prompt): 14 decisions fixed, 4 broken, p ≈ 0.03. The cases come from the same generator as the training data, so this measures the workflow, not real-world ability. Do not quote the older "111 vs 75" — it changed the prompt and the adapter together. Source: training/coordinator/deployed_ablation.md.</a:t>
+              <a:t>[3:30–4:10 · Ali · 40 s]</a:t>
+            </a:r>
+          </a:p>
+          <a:p>
+            <a:r>
+              <a:t>"Three reasons to trust it. One: the AI runs on this laptop — no cloud, no student data leaves the university. We tested our coordinator agent on 120 synthetic decisions: a better prompt took the base model from 75 to 96 correct, and fine-tuning added about 10 more, to 106.</a:t>
+            </a:r>
+          </a:p>
+          <a:p>
+            <a:r>
+              <a:t>Two: the AI never decides a hard rule or the final outcome. A solver finds valid timetables and a separate validator re-checks every one.</a:t>
+            </a:r>
+          </a:p>
+          <a:p>
+            <a:r>
+              <a:t>Three: 99 automated tests and three browser test suites pass, and Arabic and English always show the same numbers."</a:t>
+            </a:r>
+          </a:p>
+          <a:p>
+            <a:r>
+              <a:t>Q&amp;A: fine-tuning alone fixed 14 decisions and broke 4 (p ≈ 0.03); the test cases come from the same generator as the training data. Never quote "111".</a:t>
             </a:r>
           </a:p>
         </p:txBody>
@@ -1492,12 +1168,27 @@
           <a:lstStyle/>
           <a:p>
             <a:r>
-              <a:rPr lang="en-US" dirty="0"/>
-              <a:t>[Speaker 4 · 4:20–5:00]
-"What it gives: students get fewer idle hours and campus days, and the research says that means more reasons to attend. The committee checks every change in seconds, with evidence instead of email threads. The university sees unused room capacity and keeps its data on campus.
-Next: a pilot with one college using real Edugate exports, then real room bookings and instructors, and we measure attendance before and after.
-Every hour matters. Thank you."
-Likely questions: Is the data real? (Demo semester is synthetic; the Edugate import uses a real schedule.) Will students lose their preferred times? (Changes need committee approval; 0 students worse off is a constraint we report.) Cost? (Runs on one university PC; no cloud fees.)</a:t>
+              <a:t>[4:10–4:50 · Mishary · 40 s] then [4:50–5:00 · Sultan · 10 s]</a:t>
+            </a:r>
+          </a:p>
+          <a:p>
+            <a:r>
+              <a:t>MISHARY: "For students: fewer idle hours and campus days, so more reasons to attend. For the committee: every change checked in seconds, with evidence instead of email threads. For the university: unused rooms made visible, and data that stays on campus.</a:t>
+            </a:r>
+          </a:p>
+          <a:p>
+            <a:r>
+              <a:t>Next: a pilot with one college on real Edugate data with verified rooms and instructors; then a semester calendar for one-off changes, exams and Ramadan timings; then approvals and notices so students are told when their timetable changes."</a:t>
+            </a:r>
+          </a:p>
+          <a:p>
+            <a:r>
+              <a:t>SULTAN: "Every hour matters. Thank you — we're happy to take questions."</a:t>
+            </a:r>
+          </a:p>
+          <a:p>
+            <a:r>
+              <a:t>Q&amp;A owners: problem and research → Sultan; AI, solver, data and security → Ali; value, pilot, cost and users → Mishary. Staffing example if asked: "36 of the 112 students who need Machine Learning would have no seat." </a:t>
             </a:r>
           </a:p>
         </p:txBody>
@@ -1740,7 +1431,7 @@
           </a:prstGeom>
           <a:extLst>
             <a:ext uri="{C572A759-6A51-4108-AA02-DFA0A04FC94B}">
-              <ma14:wrappingTextBoxFlag xmlns:ma14="http://schemas.microsoft.com/office/mac/drawingml/2011/main" xmlns="" val="0"/>
+              <ma14:wrappingTextBoxFlag xmlns="" xmlns:ma14="http://schemas.microsoft.com/office/mac/drawingml/2011/main" val="0"/>
             </a:ext>
           </a:extLst>
         </p:spPr>
@@ -1818,7 +1509,7 @@
           </a:prstGeom>
           <a:extLst>
             <a:ext uri="{C572A759-6A51-4108-AA02-DFA0A04FC94B}">
-              <ma14:wrappingTextBoxFlag xmlns:ma14="http://schemas.microsoft.com/office/mac/drawingml/2011/main" xmlns="" val="0"/>
+              <ma14:wrappingTextBoxFlag xmlns="" xmlns:ma14="http://schemas.microsoft.com/office/mac/drawingml/2011/main" val="0"/>
             </a:ext>
           </a:extLst>
         </p:spPr>
@@ -3490,7 +3181,7 @@
           </a:prstGeom>
           <a:extLst>
             <a:ext uri="{C572A759-6A51-4108-AA02-DFA0A04FC94B}">
-              <ma14:wrappingTextBoxFlag xmlns:ma14="http://schemas.microsoft.com/office/mac/drawingml/2011/main" xmlns="" val="0"/>
+              <ma14:wrappingTextBoxFlag xmlns="" xmlns:ma14="http://schemas.microsoft.com/office/mac/drawingml/2011/main" val="0"/>
             </a:ext>
           </a:extLst>
         </p:spPr>
@@ -3988,7 +3679,7 @@
                 <a:ea typeface="Arial" pitchFamily="34" charset="-122"/>
                 <a:cs typeface="Arial" pitchFamily="34" charset="-120"/>
               </a:rPr>
-              <a:t>In our demo semester, moving one section to Sunday 10:00 creates 77 student clashes.</a:t>
+              <a:t>In our demo semester, moving one section to Sunday 10:00 creates 77 conflicts. Mizan explains each one and offers 3 valid alternatives.</a:t>
             </a:r>
             <a:endParaRPr lang="en-US" sz="3390" dirty="0"/>
           </a:p>
@@ -4540,7 +4231,7 @@
           </a:prstGeom>
           <a:extLst>
             <a:ext uri="{C572A759-6A51-4108-AA02-DFA0A04FC94B}">
-              <ma14:wrappingTextBoxFlag xmlns:ma14="http://schemas.microsoft.com/office/mac/drawingml/2011/main" xmlns="" val="0"/>
+              <ma14:wrappingTextBoxFlag xmlns="" xmlns:ma14="http://schemas.microsoft.com/office/mac/drawingml/2011/main" val="0"/>
             </a:ext>
           </a:extLst>
         </p:spPr>
@@ -5530,7 +5221,7 @@
                 <a:ea typeface="Arial" pitchFamily="34" charset="-122"/>
                 <a:cs typeface="Arial" pitchFamily="34" charset="-120"/>
               </a:rPr>
-              <a:t>The committee reviews the evidence. Nothing is published without a person.</a:t>
+              <a:t>Benefit and harm side by side. Nothing is published without a person.</a:t>
             </a:r>
             <a:endParaRPr lang="en-US" sz="3140" dirty="0"/>
           </a:p>
@@ -6191,7 +5882,7 @@
           </a:prstGeom>
           <a:extLst>
             <a:ext uri="{C572A759-6A51-4108-AA02-DFA0A04FC94B}">
-              <ma14:wrappingTextBoxFlag xmlns:ma14="http://schemas.microsoft.com/office/mac/drawingml/2011/main" xmlns="" val="0"/>
+              <ma14:wrappingTextBoxFlag xmlns="" xmlns:ma14="http://schemas.microsoft.com/office/mac/drawingml/2011/main" val="0"/>
             </a:ext>
           </a:extLst>
         </p:spPr>
@@ -6228,912 +5919,6 @@
 </file>
 
 <file path=ppt/slides/slide5.xml><?xml version="1.0" encoding="utf-8"?>
-<p:sld xmlns:a="http://schemas.openxmlformats.org/drawingml/2006/main" xmlns:r="http://schemas.openxmlformats.org/officeDocument/2006/relationships" xmlns:p="http://schemas.openxmlformats.org/presentationml/2006/main">
-  <p:cSld name="Slide 5">
-    <p:spTree>
-      <p:nvGrpSpPr>
-        <p:cNvPr id="1" name=""/>
-        <p:cNvGrpSpPr/>
-        <p:nvPr/>
-      </p:nvGrpSpPr>
-      <p:grpSpPr>
-        <a:xfrm>
-          <a:off x="0" y="0"/>
-          <a:ext cx="0" cy="0"/>
-          <a:chOff x="0" y="0"/>
-          <a:chExt cx="0" cy="0"/>
-        </a:xfrm>
-      </p:grpSpPr>
-      <p:sp>
-        <p:nvSpPr>
-          <p:cNvPr id="2" name="Text 0"/>
-          <p:cNvSpPr>
-            <a:spLocks noGrp="1"/>
-          </p:cNvSpPr>
-          <p:nvPr>
-            <p:ph type="title" idx="100" hasCustomPrompt="1"/>
-          </p:nvPr>
-        </p:nvSpPr>
-        <p:spPr>
-          <a:xfrm>
-            <a:off x="1327069" y="928939"/>
-            <a:ext cx="26762293" cy="1769364"/>
-          </a:xfrm>
-          <a:prstGeom prst="rect">
-            <a:avLst/>
-          </a:prstGeom>
-          <a:noFill/>
-          <a:ln/>
-        </p:spPr>
-        <p:txBody>
-          <a:bodyPr wrap="square" lIns="0" tIns="0" rIns="0" bIns="0" rtlCol="0" anchor="t"/>
-          <a:lstStyle/>
-          <a:p>
-            <a:pPr marL="0" indent="0" algn="l">
-              <a:buNone/>
-            </a:pPr>
-            <a:r>
-              <a:rPr lang="en-US" sz="7260" dirty="0">
-                <a:solidFill>
-                  <a:schemeClr val="tx1"/>
-                </a:solidFill>
-                <a:latin typeface="Georgia" pitchFamily="34" charset="0"/>
-                <a:ea typeface="Georgia" pitchFamily="34" charset="-122"/>
-                <a:cs typeface="Georgia" pitchFamily="34" charset="-120"/>
-              </a:rPr>
-              <a:t>Live demo: a whole semester improved in 15 seconds</a:t>
-            </a:r>
-            <a:endParaRPr lang="en-US" sz="7260" dirty="0"/>
-          </a:p>
-        </p:txBody>
-      </p:sp>
-      <p:sp>
-        <p:nvSpPr>
-          <p:cNvPr id="3" name="Screenshot frame"/>
-          <p:cNvSpPr/>
-          <p:nvPr/>
-        </p:nvSpPr>
-        <p:spPr>
-          <a:xfrm>
-            <a:off x="1327069" y="3317626"/>
-            <a:ext cx="16698773" cy="10903946"/>
-          </a:xfrm>
-          <a:prstGeom prst="rect">
-            <a:avLst/>
-          </a:prstGeom>
-          <a:solidFill>
-            <a:srgbClr val="FFFFFF"/>
-          </a:solidFill>
-          <a:ln w="12700">
-            <a:solidFill>
-              <a:srgbClr val="E3DBCF"/>
-            </a:solidFill>
-            <a:prstDash val="solid"/>
-          </a:ln>
-        </p:spPr>
-        <p:txBody>
-          <a:bodyPr/>
-          <a:lstStyle/>
-          <a:p>
-            <a:endParaRPr lang="en-US"/>
-          </a:p>
-        </p:txBody>
-      </p:sp>
-      <p:pic>
-        <p:nvPicPr>
-          <p:cNvPr id="4" name="Mizan overview screenshot" descr="C:\Users\Admin\AppData\Local\Temp\claude\C--Users-Admin-Documents-GitHub-Mizan\b7a3e5b0-497b-48e5-8b06-72387145df4d\scratchpad\deck\img_overview.png"/>
-          <p:cNvPicPr>
-            <a:picLocks noChangeAspect="1"/>
-          </p:cNvPicPr>
-          <p:nvPr/>
-        </p:nvPicPr>
-        <p:blipFill>
-          <a:blip r:embed="rId3"/>
-          <a:srcRect/>
-          <a:stretch/>
-        </p:blipFill>
-        <p:spPr>
-          <a:xfrm>
-            <a:off x="1504005" y="3494562"/>
-            <a:ext cx="16344900" cy="10550073"/>
-          </a:xfrm>
-          <a:prstGeom prst="rect">
-            <a:avLst/>
-          </a:prstGeom>
-        </p:spPr>
-      </p:pic>
-      <p:graphicFrame>
-        <p:nvGraphicFramePr>
-          <p:cNvPr id="5" name="Before after chart"/>
-          <p:cNvGraphicFramePr/>
-          <p:nvPr/>
-        </p:nvGraphicFramePr>
-        <p:xfrm>
-          <a:off x="18910524" y="3207075"/>
-          <a:ext cx="9289390" cy="5418826"/>
-        </p:xfrm>
-        <a:graphic>
-          <a:graphicData uri="http://schemas.openxmlformats.org/drawingml/2006/chart">
-            <c:chart xmlns:c="http://schemas.openxmlformats.org/drawingml/2006/chart" xmlns:r="http://schemas.openxmlformats.org/officeDocument/2006/relationships" r:id="rId4"/>
-          </a:graphicData>
-        </a:graphic>
-      </p:graphicFrame>
-      <p:sp>
-        <p:nvSpPr>
-          <p:cNvPr id="6" name="Demo fact 1"/>
-          <p:cNvSpPr txBox="1"/>
-          <p:nvPr/>
-        </p:nvSpPr>
-        <p:spPr>
-          <a:xfrm>
-            <a:off x="19021166" y="8736452"/>
-            <a:ext cx="2985882" cy="1327069"/>
-          </a:xfrm>
-          <a:prstGeom prst="rect">
-            <a:avLst/>
-          </a:prstGeom>
-          <a:noFill/>
-          <a:ln/>
-        </p:spPr>
-        <p:txBody>
-          <a:bodyPr wrap="square" lIns="0" tIns="0" rIns="0" bIns="0" rtlCol="0" anchor="ctr"/>
-          <a:lstStyle/>
-          <a:p>
-            <a:pPr marL="0" indent="0">
-              <a:buNone/>
-            </a:pPr>
-            <a:r>
-              <a:rPr lang="en-US" sz="5810" dirty="0">
-                <a:solidFill>
-                  <a:srgbClr val="529573"/>
-                </a:solidFill>
-                <a:latin typeface="Arial" pitchFamily="34" charset="0"/>
-                <a:ea typeface="Arial" pitchFamily="34" charset="-122"/>
-                <a:cs typeface="Arial" pitchFamily="34" charset="-120"/>
-              </a:rPr>
-              <a:t>≈1,800</a:t>
-            </a:r>
-            <a:endParaRPr lang="en-US" sz="5810" dirty="0"/>
-          </a:p>
-        </p:txBody>
-      </p:sp>
-      <p:sp>
-        <p:nvSpPr>
-          <p:cNvPr id="7" name="Demo fact label 1"/>
-          <p:cNvSpPr txBox="1"/>
-          <p:nvPr/>
-        </p:nvSpPr>
-        <p:spPr>
-          <a:xfrm>
-            <a:off x="22117599" y="8736452"/>
-            <a:ext cx="6082314" cy="1327069"/>
-          </a:xfrm>
-          <a:prstGeom prst="rect">
-            <a:avLst/>
-          </a:prstGeom>
-          <a:noFill/>
-          <a:ln/>
-        </p:spPr>
-        <p:txBody>
-          <a:bodyPr wrap="square" lIns="0" tIns="0" rIns="0" bIns="0" rtlCol="0" anchor="ctr"/>
-          <a:lstStyle/>
-          <a:p>
-            <a:pPr marL="0" indent="0">
-              <a:buNone/>
-            </a:pPr>
-            <a:r>
-              <a:rPr lang="en-US" sz="3140" dirty="0">
-                <a:solidFill>
-                  <a:schemeClr val="tx1"/>
-                </a:solidFill>
-                <a:latin typeface="Arial" pitchFamily="34" charset="0"/>
-                <a:ea typeface="Arial" pitchFamily="34" charset="-122"/>
-                <a:cs typeface="Arial" pitchFamily="34" charset="-120"/>
-              </a:rPr>
-              <a:t>student-hours a week given back</a:t>
-            </a:r>
-            <a:endParaRPr lang="en-US" sz="3140" dirty="0"/>
-          </a:p>
-        </p:txBody>
-      </p:sp>
-      <p:sp>
-        <p:nvSpPr>
-          <p:cNvPr id="8" name="Demo fact 2"/>
-          <p:cNvSpPr txBox="1"/>
-          <p:nvPr/>
-        </p:nvSpPr>
-        <p:spPr>
-          <a:xfrm>
-            <a:off x="19021166" y="10107778"/>
-            <a:ext cx="2985882" cy="1327069"/>
-          </a:xfrm>
-          <a:prstGeom prst="rect">
-            <a:avLst/>
-          </a:prstGeom>
-          <a:noFill/>
-          <a:ln/>
-        </p:spPr>
-        <p:txBody>
-          <a:bodyPr wrap="square" lIns="0" tIns="0" rIns="0" bIns="0" rtlCol="0" anchor="ctr"/>
-          <a:lstStyle/>
-          <a:p>
-            <a:pPr marL="0" indent="0">
-              <a:buNone/>
-            </a:pPr>
-            <a:r>
-              <a:rPr lang="en-US" sz="5810" dirty="0">
-                <a:solidFill>
-                  <a:srgbClr val="529573"/>
-                </a:solidFill>
-                <a:latin typeface="Arial" pitchFamily="34" charset="0"/>
-                <a:ea typeface="Arial" pitchFamily="34" charset="-122"/>
-                <a:cs typeface="Arial" pitchFamily="34" charset="-120"/>
-              </a:rPr>
-              <a:t>0</a:t>
-            </a:r>
-            <a:endParaRPr lang="en-US" sz="5810" dirty="0"/>
-          </a:p>
-        </p:txBody>
-      </p:sp>
-      <p:sp>
-        <p:nvSpPr>
-          <p:cNvPr id="9" name="Demo fact label 2"/>
-          <p:cNvSpPr txBox="1"/>
-          <p:nvPr/>
-        </p:nvSpPr>
-        <p:spPr>
-          <a:xfrm>
-            <a:off x="22117599" y="10107778"/>
-            <a:ext cx="6082314" cy="1327069"/>
-          </a:xfrm>
-          <a:prstGeom prst="rect">
-            <a:avLst/>
-          </a:prstGeom>
-          <a:noFill/>
-          <a:ln/>
-        </p:spPr>
-        <p:txBody>
-          <a:bodyPr wrap="square" lIns="0" tIns="0" rIns="0" bIns="0" rtlCol="0" anchor="ctr"/>
-          <a:lstStyle/>
-          <a:p>
-            <a:pPr marL="0" indent="0">
-              <a:buNone/>
-            </a:pPr>
-            <a:r>
-              <a:rPr lang="en-US" sz="3140" dirty="0">
-                <a:solidFill>
-                  <a:schemeClr val="tx1"/>
-                </a:solidFill>
-                <a:latin typeface="Arial" pitchFamily="34" charset="0"/>
-                <a:ea typeface="Arial" pitchFamily="34" charset="-122"/>
-                <a:cs typeface="Arial" pitchFamily="34" charset="-120"/>
-              </a:rPr>
-              <a:t>students with a worse week</a:t>
-            </a:r>
-            <a:endParaRPr lang="en-US" sz="3140" dirty="0"/>
-          </a:p>
-        </p:txBody>
-      </p:sp>
-      <p:sp>
-        <p:nvSpPr>
-          <p:cNvPr id="10" name="Demo fact 3"/>
-          <p:cNvSpPr txBox="1"/>
-          <p:nvPr/>
-        </p:nvSpPr>
-        <p:spPr>
-          <a:xfrm>
-            <a:off x="19021166" y="11479012"/>
-            <a:ext cx="2985882" cy="1327069"/>
-          </a:xfrm>
-          <a:prstGeom prst="rect">
-            <a:avLst/>
-          </a:prstGeom>
-          <a:noFill/>
-          <a:ln/>
-        </p:spPr>
-        <p:txBody>
-          <a:bodyPr wrap="square" lIns="0" tIns="0" rIns="0" bIns="0" rtlCol="0" anchor="ctr"/>
-          <a:lstStyle/>
-          <a:p>
-            <a:pPr marL="0" indent="0">
-              <a:buNone/>
-            </a:pPr>
-            <a:r>
-              <a:rPr lang="en-US" sz="5810" dirty="0">
-                <a:solidFill>
-                  <a:srgbClr val="4B6C9F"/>
-                </a:solidFill>
-                <a:latin typeface="Arial" pitchFamily="34" charset="0"/>
-                <a:ea typeface="Arial" pitchFamily="34" charset="-122"/>
-                <a:cs typeface="Arial" pitchFamily="34" charset="-120"/>
-              </a:rPr>
-              <a:t>100%</a:t>
-            </a:r>
-            <a:endParaRPr lang="en-US" sz="5810" dirty="0"/>
-          </a:p>
-        </p:txBody>
-      </p:sp>
-      <p:sp>
-        <p:nvSpPr>
-          <p:cNvPr id="11" name="Demo fact label 3"/>
-          <p:cNvSpPr txBox="1"/>
-          <p:nvPr/>
-        </p:nvSpPr>
-        <p:spPr>
-          <a:xfrm>
-            <a:off x="22117599" y="11479012"/>
-            <a:ext cx="6082314" cy="1327069"/>
-          </a:xfrm>
-          <a:prstGeom prst="rect">
-            <a:avLst/>
-          </a:prstGeom>
-          <a:noFill/>
-          <a:ln/>
-        </p:spPr>
-        <p:txBody>
-          <a:bodyPr wrap="square" lIns="0" tIns="0" rIns="0" bIns="0" rtlCol="0" anchor="ctr"/>
-          <a:lstStyle/>
-          <a:p>
-            <a:pPr marL="0" indent="0">
-              <a:buNone/>
-            </a:pPr>
-            <a:r>
-              <a:rPr lang="en-US" sz="3140" dirty="0">
-                <a:solidFill>
-                  <a:schemeClr val="tx1"/>
-                </a:solidFill>
-                <a:latin typeface="Arial" pitchFamily="34" charset="0"/>
-                <a:ea typeface="Arial" pitchFamily="34" charset="-122"/>
-                <a:cs typeface="Arial" pitchFamily="34" charset="-120"/>
-              </a:rPr>
-              <a:t>of results re-checked by an independent validator</a:t>
-            </a:r>
-            <a:endParaRPr lang="en-US" sz="3140" dirty="0"/>
-          </a:p>
-        </p:txBody>
-      </p:sp>
-      <p:sp>
-        <p:nvSpPr>
-          <p:cNvPr id="12" name="Synthetic data note"/>
-          <p:cNvSpPr txBox="1"/>
-          <p:nvPr/>
-        </p:nvSpPr>
-        <p:spPr>
-          <a:xfrm>
-            <a:off x="19021166" y="13049402"/>
-            <a:ext cx="9178839" cy="995324"/>
-          </a:xfrm>
-          <a:prstGeom prst="rect">
-            <a:avLst/>
-          </a:prstGeom>
-          <a:noFill/>
-          <a:ln/>
-        </p:spPr>
-        <p:txBody>
-          <a:bodyPr wrap="square" lIns="0" tIns="0" rIns="0" bIns="0" rtlCol="0" anchor="t"/>
-          <a:lstStyle/>
-          <a:p>
-            <a:pPr marL="0" indent="0">
-              <a:buNone/>
-            </a:pPr>
-            <a:r>
-              <a:rPr lang="en-US" sz="2420" dirty="0">
-                <a:solidFill>
-                  <a:srgbClr val="68645B"/>
-                </a:solidFill>
-                <a:latin typeface="Arial" pitchFamily="34" charset="0"/>
-                <a:ea typeface="Arial" pitchFamily="34" charset="-122"/>
-                <a:cs typeface="Arial" pitchFamily="34" charset="-120"/>
-              </a:rPr>
-              <a:t>Demo semester: 1,500 synthetic students. The start is deliberately poor (identical cohorts, 10 h of gaps each), so the first moves are obvious; the point is that every change is checked and approved.</a:t>
-            </a:r>
-            <a:endParaRPr lang="en-US" sz="2420" dirty="0"/>
-          </a:p>
-        </p:txBody>
-      </p:sp>
-      <p:sp>
-        <p:nvSpPr>
-          <p:cNvPr id="25" name="Slide Number Placeholder 0"/>
-          <p:cNvSpPr>
-            <a:spLocks noGrp="1"/>
-          </p:cNvSpPr>
-          <p:nvPr>
-            <p:ph type="sldNum" sz="quarter" idx="4294967295"/>
-          </p:nvPr>
-        </p:nvSpPr>
-        <p:spPr>
-          <a:xfrm>
-            <a:off x="27270974" y="14332214"/>
-            <a:ext cx="884682" cy="552938"/>
-          </a:xfrm>
-          <a:prstGeom prst="rect">
-            <a:avLst/>
-          </a:prstGeom>
-          <a:extLst>
-            <a:ext uri="{C572A759-6A51-4108-AA02-DFA0A04FC94B}">
-              <ma14:wrappingTextBoxFlag xmlns:ma14="http://schemas.microsoft.com/office/mac/drawingml/2011/main" xmlns="" val="0"/>
-            </a:ext>
-          </a:extLst>
-        </p:spPr>
-        <p:txBody>
-          <a:bodyPr lIns="0" tIns="0" rIns="0" bIns="0"/>
-          <a:lstStyle>
-            <a:lvl1pPr>
-              <a:defRPr sz="2180">
-                <a:solidFill>
-                  <a:srgbClr val="68645B"/>
-                </a:solidFill>
-                <a:latin typeface="Arial"/>
-                <a:ea typeface="Arial"/>
-                <a:cs typeface="Arial"/>
-              </a:defRPr>
-            </a:lvl1pPr>
-          </a:lstStyle>
-          <a:p>
-            <a:pPr algn="r"/>
-            <a:fld id="{F7021451-1387-4CA6-816F-3879F97B5CBC}" type="slidenum">
-              <a:rPr lang="en-US" b="0"/>
-              <a:t>5</a:t>
-            </a:fld>
-            <a:endParaRPr lang="en-US"/>
-          </a:p>
-        </p:txBody>
-      </p:sp>
-    </p:spTree>
-  </p:cSld>
-  <p:clrMapOvr>
-    <a:masterClrMapping/>
-  </p:clrMapOvr>
-</p:sld>
-</file>
-
-<file path=ppt/slides/slide6.xml><?xml version="1.0" encoding="utf-8"?>
-<p:sld xmlns:a="http://schemas.openxmlformats.org/drawingml/2006/main" xmlns:r="http://schemas.openxmlformats.org/officeDocument/2006/relationships" xmlns:p="http://schemas.openxmlformats.org/presentationml/2006/main">
-  <p:cSld name="Slide 6">
-    <p:spTree>
-      <p:nvGrpSpPr>
-        <p:cNvPr id="1" name=""/>
-        <p:cNvGrpSpPr/>
-        <p:nvPr/>
-      </p:nvGrpSpPr>
-      <p:grpSpPr>
-        <a:xfrm>
-          <a:off x="0" y="0"/>
-          <a:ext cx="0" cy="0"/>
-          <a:chOff x="0" y="0"/>
-          <a:chExt cx="0" cy="0"/>
-        </a:xfrm>
-      </p:grpSpPr>
-      <p:sp>
-        <p:nvSpPr>
-          <p:cNvPr id="2" name="Text 0"/>
-          <p:cNvSpPr>
-            <a:spLocks noGrp="1"/>
-          </p:cNvSpPr>
-          <p:nvPr>
-            <p:ph type="title" idx="100" hasCustomPrompt="1"/>
-          </p:nvPr>
-        </p:nvSpPr>
-        <p:spPr>
-          <a:xfrm>
-            <a:off x="1327069" y="928939"/>
-            <a:ext cx="26762293" cy="1769364"/>
-          </a:xfrm>
-          <a:prstGeom prst="rect">
-            <a:avLst/>
-          </a:prstGeom>
-          <a:noFill/>
-          <a:ln/>
-        </p:spPr>
-        <p:txBody>
-          <a:bodyPr wrap="square" lIns="0" tIns="0" rIns="0" bIns="0" rtlCol="0" anchor="t"/>
-          <a:lstStyle/>
-          <a:p>
-            <a:pPr marL="0" indent="0" algn="l">
-              <a:buNone/>
-            </a:pPr>
-            <a:r>
-              <a:rPr lang="en-US" sz="7260" dirty="0">
-                <a:solidFill>
-                  <a:schemeClr val="tx1"/>
-                </a:solidFill>
-                <a:latin typeface="Georgia" pitchFamily="34" charset="0"/>
-                <a:ea typeface="Georgia" pitchFamily="34" charset="-122"/>
-                <a:cs typeface="Georgia" pitchFamily="34" charset="-120"/>
-              </a:rPr>
-              <a:t>Your real Edugate schedule in, a better one out</a:t>
-            </a:r>
-            <a:endParaRPr lang="en-US" sz="7260" dirty="0"/>
-          </a:p>
-        </p:txBody>
-      </p:sp>
-      <p:sp>
-        <p:nvSpPr>
-          <p:cNvPr id="3" name="Edugate frame 1"/>
-          <p:cNvSpPr/>
-          <p:nvPr/>
-        </p:nvSpPr>
-        <p:spPr>
-          <a:xfrm>
-            <a:off x="1327069" y="3317626"/>
-            <a:ext cx="13049402" cy="8802837"/>
-          </a:xfrm>
-          <a:prstGeom prst="rect">
-            <a:avLst/>
-          </a:prstGeom>
-          <a:solidFill>
-            <a:srgbClr val="FFFFFF"/>
-          </a:solidFill>
-          <a:ln w="12700">
-            <a:solidFill>
-              <a:srgbClr val="E3DBCF"/>
-            </a:solidFill>
-            <a:prstDash val="solid"/>
-          </a:ln>
-        </p:spPr>
-        <p:txBody>
-          <a:bodyPr/>
-          <a:lstStyle/>
-          <a:p>
-            <a:endParaRPr lang="en-US"/>
-          </a:p>
-        </p:txBody>
-      </p:sp>
-      <p:pic>
-        <p:nvPicPr>
-          <p:cNvPr id="4" name="Edugate screenshot 1" descr="C:\Users\Admin\AppData\Local\Temp\claude\C--Users-Admin-Documents-GitHub-Mizan\b7a3e5b0-497b-48e5-8b06-72387145df4d\scratchpad\deck\img_review.png"/>
-          <p:cNvPicPr>
-            <a:picLocks noChangeAspect="1"/>
-          </p:cNvPicPr>
-          <p:nvPr/>
-        </p:nvPicPr>
-        <p:blipFill>
-          <a:blip r:embed="rId3"/>
-          <a:srcRect/>
-          <a:stretch/>
-        </p:blipFill>
-        <p:spPr>
-          <a:xfrm>
-            <a:off x="1504005" y="3494562"/>
-            <a:ext cx="12695530" cy="8448965"/>
-          </a:xfrm>
-          <a:prstGeom prst="rect">
-            <a:avLst/>
-          </a:prstGeom>
-        </p:spPr>
-      </p:pic>
-      <p:sp>
-        <p:nvSpPr>
-          <p:cNvPr id="5" name="Edugate step bg 1"/>
-          <p:cNvSpPr/>
-          <p:nvPr/>
-        </p:nvSpPr>
-        <p:spPr>
-          <a:xfrm>
-            <a:off x="1327069" y="12562759"/>
-            <a:ext cx="973196" cy="973196"/>
-          </a:xfrm>
-          <a:prstGeom prst="ellipse">
-            <a:avLst/>
-          </a:prstGeom>
-          <a:solidFill>
-            <a:srgbClr val="F4A252"/>
-          </a:solidFill>
-          <a:ln w="12700">
-            <a:solidFill>
-              <a:srgbClr val="F4A252"/>
-            </a:solidFill>
-            <a:prstDash val="solid"/>
-          </a:ln>
-        </p:spPr>
-        <p:txBody>
-          <a:bodyPr/>
-          <a:lstStyle/>
-          <a:p>
-            <a:endParaRPr lang="en-US"/>
-          </a:p>
-        </p:txBody>
-      </p:sp>
-      <p:sp>
-        <p:nvSpPr>
-          <p:cNvPr id="6" name="Edugate step 1"/>
-          <p:cNvSpPr txBox="1"/>
-          <p:nvPr/>
-        </p:nvSpPr>
-        <p:spPr>
-          <a:xfrm>
-            <a:off x="1327069" y="12562759"/>
-            <a:ext cx="973196" cy="973196"/>
-          </a:xfrm>
-          <a:prstGeom prst="rect">
-            <a:avLst/>
-          </a:prstGeom>
-          <a:noFill/>
-          <a:ln/>
-        </p:spPr>
-        <p:txBody>
-          <a:bodyPr wrap="square" lIns="0" tIns="0" rIns="0" bIns="0" rtlCol="0" anchor="ctr"/>
-          <a:lstStyle/>
-          <a:p>
-            <a:pPr marL="0" indent="0" algn="ctr">
-              <a:buNone/>
-            </a:pPr>
-            <a:r>
-              <a:rPr lang="en-US" sz="3390" b="1" dirty="0">
-                <a:solidFill>
-                  <a:srgbClr val="111C21"/>
-                </a:solidFill>
-                <a:latin typeface="Arial" pitchFamily="34" charset="0"/>
-                <a:ea typeface="Arial" pitchFamily="34" charset="-122"/>
-                <a:cs typeface="Arial" pitchFamily="34" charset="-120"/>
-              </a:rPr>
-              <a:t>1</a:t>
-            </a:r>
-            <a:endParaRPr lang="en-US" sz="3390" dirty="0"/>
-          </a:p>
-        </p:txBody>
-      </p:sp>
-      <p:sp>
-        <p:nvSpPr>
-          <p:cNvPr id="7" name="Edugate caption 1"/>
-          <p:cNvSpPr txBox="1"/>
-          <p:nvPr/>
-        </p:nvSpPr>
-        <p:spPr>
-          <a:xfrm>
-            <a:off x="2654137" y="12518593"/>
-            <a:ext cx="11722334" cy="1327069"/>
-          </a:xfrm>
-          <a:prstGeom prst="rect">
-            <a:avLst/>
-          </a:prstGeom>
-          <a:noFill/>
-          <a:ln/>
-        </p:spPr>
-        <p:txBody>
-          <a:bodyPr wrap="square" lIns="0" tIns="0" rIns="0" bIns="0" rtlCol="0" anchor="ctr"/>
-          <a:lstStyle/>
-          <a:p>
-            <a:pPr marL="0" indent="0">
-              <a:buNone/>
-            </a:pPr>
-            <a:r>
-              <a:rPr lang="en-US" sz="3390" dirty="0">
-                <a:solidFill>
-                  <a:schemeClr val="tx1"/>
-                </a:solidFill>
-                <a:latin typeface="Arial" pitchFamily="34" charset="0"/>
-                <a:ea typeface="Arial" pitchFamily="34" charset="-122"/>
-                <a:cs typeface="Arial" pitchFamily="34" charset="-120"/>
-              </a:rPr>
-              <a:t>Read an Edugate PDF or app screenshot on this PC, then check every row</a:t>
-            </a:r>
-            <a:endParaRPr lang="en-US" sz="3390" dirty="0"/>
-          </a:p>
-        </p:txBody>
-      </p:sp>
-      <p:sp>
-        <p:nvSpPr>
-          <p:cNvPr id="8" name="Edugate frame 2"/>
-          <p:cNvSpPr/>
-          <p:nvPr/>
-        </p:nvSpPr>
-        <p:spPr>
-          <a:xfrm>
-            <a:off x="15039960" y="3317626"/>
-            <a:ext cx="13049402" cy="8802837"/>
-          </a:xfrm>
-          <a:prstGeom prst="rect">
-            <a:avLst/>
-          </a:prstGeom>
-          <a:solidFill>
-            <a:srgbClr val="FFFFFF"/>
-          </a:solidFill>
-          <a:ln w="12700">
-            <a:solidFill>
-              <a:srgbClr val="E3DBCF"/>
-            </a:solidFill>
-            <a:prstDash val="solid"/>
-          </a:ln>
-        </p:spPr>
-        <p:txBody>
-          <a:bodyPr/>
-          <a:lstStyle/>
-          <a:p>
-            <a:endParaRPr lang="en-US"/>
-          </a:p>
-        </p:txBody>
-      </p:sp>
-      <p:pic>
-        <p:nvPicPr>
-          <p:cNvPr id="9" name="Edugate screenshot 2" descr="C:\Users\Admin\AppData\Local\Temp\claude\C--Users-Admin-Documents-GitHub-Mizan\b7a3e5b0-497b-48e5-8b06-72387145df4d\scratchpad\deck\img_export_crop.png"/>
-          <p:cNvPicPr>
-            <a:picLocks noChangeAspect="1"/>
-          </p:cNvPicPr>
-          <p:nvPr/>
-        </p:nvPicPr>
-        <p:blipFill>
-          <a:blip r:embed="rId4"/>
-          <a:srcRect/>
-          <a:stretch/>
-        </p:blipFill>
-        <p:spPr>
-          <a:xfrm>
-            <a:off x="15216896" y="3494562"/>
-            <a:ext cx="12695530" cy="8448965"/>
-          </a:xfrm>
-          <a:prstGeom prst="rect">
-            <a:avLst/>
-          </a:prstGeom>
-        </p:spPr>
-      </p:pic>
-      <p:sp>
-        <p:nvSpPr>
-          <p:cNvPr id="10" name="Edugate step bg 2"/>
-          <p:cNvSpPr/>
-          <p:nvPr/>
-        </p:nvSpPr>
-        <p:spPr>
-          <a:xfrm>
-            <a:off x="15039960" y="12562759"/>
-            <a:ext cx="973196" cy="973196"/>
-          </a:xfrm>
-          <a:prstGeom prst="ellipse">
-            <a:avLst/>
-          </a:prstGeom>
-          <a:solidFill>
-            <a:srgbClr val="F4A252"/>
-          </a:solidFill>
-          <a:ln w="12700">
-            <a:solidFill>
-              <a:srgbClr val="F4A252"/>
-            </a:solidFill>
-            <a:prstDash val="solid"/>
-          </a:ln>
-        </p:spPr>
-        <p:txBody>
-          <a:bodyPr/>
-          <a:lstStyle/>
-          <a:p>
-            <a:endParaRPr lang="en-US"/>
-          </a:p>
-        </p:txBody>
-      </p:sp>
-      <p:sp>
-        <p:nvSpPr>
-          <p:cNvPr id="11" name="Edugate step 2"/>
-          <p:cNvSpPr txBox="1"/>
-          <p:nvPr/>
-        </p:nvSpPr>
-        <p:spPr>
-          <a:xfrm>
-            <a:off x="15039960" y="12562759"/>
-            <a:ext cx="973196" cy="973196"/>
-          </a:xfrm>
-          <a:prstGeom prst="rect">
-            <a:avLst/>
-          </a:prstGeom>
-          <a:noFill/>
-          <a:ln/>
-        </p:spPr>
-        <p:txBody>
-          <a:bodyPr wrap="square" lIns="0" tIns="0" rIns="0" bIns="0" rtlCol="0" anchor="ctr"/>
-          <a:lstStyle/>
-          <a:p>
-            <a:pPr marL="0" indent="0" algn="ctr">
-              <a:buNone/>
-            </a:pPr>
-            <a:r>
-              <a:rPr lang="en-US" sz="3390" b="1" dirty="0">
-                <a:solidFill>
-                  <a:srgbClr val="111C21"/>
-                </a:solidFill>
-                <a:latin typeface="Arial" pitchFamily="34" charset="0"/>
-                <a:ea typeface="Arial" pitchFamily="34" charset="-122"/>
-                <a:cs typeface="Arial" pitchFamily="34" charset="-120"/>
-              </a:rPr>
-              <a:t>2</a:t>
-            </a:r>
-            <a:endParaRPr lang="en-US" sz="3390" dirty="0"/>
-          </a:p>
-        </p:txBody>
-      </p:sp>
-      <p:sp>
-        <p:nvSpPr>
-          <p:cNvPr id="12" name="Edugate caption 2"/>
-          <p:cNvSpPr txBox="1"/>
-          <p:nvPr/>
-        </p:nvSpPr>
-        <p:spPr>
-          <a:xfrm>
-            <a:off x="16367028" y="12518593"/>
-            <a:ext cx="11722334" cy="1327069"/>
-          </a:xfrm>
-          <a:prstGeom prst="rect">
-            <a:avLst/>
-          </a:prstGeom>
-          <a:noFill/>
-          <a:ln/>
-        </p:spPr>
-        <p:txBody>
-          <a:bodyPr wrap="square" lIns="0" tIns="0" rIns="0" bIns="0" rtlCol="0" anchor="ctr"/>
-          <a:lstStyle/>
-          <a:p>
-            <a:pPr marL="0" indent="0">
-              <a:buNone/>
-            </a:pPr>
-            <a:r>
-              <a:rPr lang="en-US" sz="3390" dirty="0">
-                <a:solidFill>
-                  <a:schemeClr val="tx1"/>
-                </a:solidFill>
-                <a:latin typeface="Arial" pitchFamily="34" charset="0"/>
-                <a:ea typeface="Arial" pitchFamily="34" charset="-122"/>
-                <a:cs typeface="Arial" pitchFamily="34" charset="-120"/>
-              </a:rPr>
-              <a:t>Optimize, then print the result in the Edugate layout. Changed rows are shaded</a:t>
-            </a:r>
-            <a:endParaRPr lang="en-US" sz="3390" dirty="0"/>
-          </a:p>
-        </p:txBody>
-      </p:sp>
-      <p:sp>
-        <p:nvSpPr>
-          <p:cNvPr id="25" name="Slide Number Placeholder 0"/>
-          <p:cNvSpPr>
-            <a:spLocks noGrp="1"/>
-          </p:cNvSpPr>
-          <p:nvPr>
-            <p:ph type="sldNum" sz="quarter" idx="4294967295"/>
-          </p:nvPr>
-        </p:nvSpPr>
-        <p:spPr>
-          <a:xfrm>
-            <a:off x="27270974" y="14332214"/>
-            <a:ext cx="884682" cy="552938"/>
-          </a:xfrm>
-          <a:prstGeom prst="rect">
-            <a:avLst/>
-          </a:prstGeom>
-          <a:extLst>
-            <a:ext uri="{C572A759-6A51-4108-AA02-DFA0A04FC94B}">
-              <ma14:wrappingTextBoxFlag xmlns:ma14="http://schemas.microsoft.com/office/mac/drawingml/2011/main" xmlns="" val="0"/>
-            </a:ext>
-          </a:extLst>
-        </p:spPr>
-        <p:txBody>
-          <a:bodyPr lIns="0" tIns="0" rIns="0" bIns="0"/>
-          <a:lstStyle>
-            <a:lvl1pPr>
-              <a:defRPr sz="2180">
-                <a:solidFill>
-                  <a:srgbClr val="68645B"/>
-                </a:solidFill>
-                <a:latin typeface="Arial"/>
-                <a:ea typeface="Arial"/>
-                <a:cs typeface="Arial"/>
-              </a:defRPr>
-            </a:lvl1pPr>
-          </a:lstStyle>
-          <a:p>
-            <a:pPr algn="r"/>
-            <a:fld id="{F7021451-1387-4CA6-816F-3879F97B5CBC}" type="slidenum">
-              <a:rPr lang="en-US" b="0"/>
-              <a:t>6</a:t>
-            </a:fld>
-            <a:endParaRPr lang="en-US"/>
-          </a:p>
-        </p:txBody>
-      </p:sp>
-    </p:spTree>
-  </p:cSld>
-  <p:clrMapOvr>
-    <a:masterClrMapping/>
-  </p:clrMapOvr>
-</p:sld>
-</file>
-
-<file path=ppt/slides/slide7.xml><?xml version="1.0" encoding="utf-8"?>
 <p:sld xmlns:a="http://schemas.openxmlformats.org/drawingml/2006/main" xmlns:r="http://schemas.openxmlformats.org/officeDocument/2006/relationships" xmlns:p="http://schemas.openxmlformats.org/presentationml/2006/main">
   <p:cSld name="Slide 7">
     <p:spTree>
@@ -7890,7 +6675,7 @@
           </a:prstGeom>
           <a:extLst>
             <a:ext uri="{C572A759-6A51-4108-AA02-DFA0A04FC94B}">
-              <ma14:wrappingTextBoxFlag xmlns:ma14="http://schemas.microsoft.com/office/mac/drawingml/2011/main" xmlns="" val="0"/>
+              <ma14:wrappingTextBoxFlag xmlns="" xmlns:ma14="http://schemas.microsoft.com/office/mac/drawingml/2011/main" val="0"/>
             </a:ext>
           </a:extLst>
         </p:spPr>
@@ -7926,7 +6711,7 @@
 </p:sld>
 </file>
 
-<file path=ppt/slides/slide8.xml><?xml version="1.0" encoding="utf-8"?>
+<file path=ppt/slides/slide6.xml><?xml version="1.0" encoding="utf-8"?>
 <p:sld xmlns:a="http://schemas.openxmlformats.org/drawingml/2006/main" xmlns:r="http://schemas.openxmlformats.org/officeDocument/2006/relationships" xmlns:p="http://schemas.openxmlformats.org/presentationml/2006/main">
   <p:cSld name="Slide 8">
     <p:spTree>
@@ -8337,7 +7122,7 @@
                 <a:ea typeface="Arial" pitchFamily="34" charset="-122"/>
                 <a:cs typeface="Arial" pitchFamily="34" charset="-120"/>
               </a:rPr>
-              <a:t>Real Edugate exports, one term</a:t>
+              <a:t>Real Edugate data, verified rooms and instructors</a:t>
             </a:r>
             <a:endParaRPr lang="en-US" sz="4110" dirty="0"/>
           </a:p>
@@ -8477,7 +7262,7 @@
                 <a:ea typeface="Arial" pitchFamily="34" charset="-122"/>
                 <a:cs typeface="Arial" pitchFamily="34" charset="-120"/>
               </a:rPr>
-              <a:t>Connect real data</a:t>
+              <a:t>Semester calendar</a:t>
             </a:r>
             <a:endParaRPr lang="en-US" sz="4110" dirty="0"/>
           </a:p>
@@ -8494,7 +7279,7 @@
                 <a:ea typeface="Arial" pitchFamily="34" charset="-122"/>
                 <a:cs typeface="Arial" pitchFamily="34" charset="-120"/>
               </a:rPr>
-              <a:t>Room bookings and instructors</a:t>
+              <a:t>One-off changes, exams, Ramadan timings</a:t>
             </a:r>
             <a:endParaRPr lang="en-US" sz="4110" dirty="0"/>
           </a:p>
@@ -8634,7 +7419,7 @@
                 <a:ea typeface="Arial" pitchFamily="34" charset="-122"/>
                 <a:cs typeface="Arial" pitchFamily="34" charset="-120"/>
               </a:rPr>
-              <a:t>Measure the effect</a:t>
+              <a:t>Approvals and notices</a:t>
             </a:r>
             <a:endParaRPr lang="en-US" sz="4110" dirty="0"/>
           </a:p>
@@ -8651,7 +7436,7 @@
                 <a:ea typeface="Arial" pitchFamily="34" charset="-122"/>
                 <a:cs typeface="Arial" pitchFamily="34" charset="-120"/>
               </a:rPr>
-              <a:t>Attendance before and after</a:t>
+              <a:t>Department, then registrar; students are told</a:t>
             </a:r>
             <a:endParaRPr lang="en-US" sz="4110" dirty="0"/>
           </a:p>

</xml_diff>